<commit_message>
Poster: neural baseline box becomes a two-approaches comparison (NVARC reproduction 27.64%, not CORA; CORA 0.00%) with the open neural-symbolic question
</commit_message>
<xml_diff>
--- a/docs/summit_20261023_reframe/poster_visual_final_review.pptx
+++ b/docs/summit_20261023_reframe/poster_visual_final_review.pptx
@@ -3520,7 +3520,7 @@
         </p:blipFill>
         <p:spPr>
           <a:xfrm>
-            <a:off x="850851" y="40416971"/>
+            <a:off x="850851" y="40452963"/>
             <a:ext cx="3526990" cy="719401"/>
           </a:xfrm>
           <a:prstGeom prst="rect">
@@ -3544,7 +3544,7 @@
         </p:blipFill>
         <p:spPr>
           <a:xfrm>
-            <a:off x="4495544" y="40416971"/>
+            <a:off x="4495544" y="40452963"/>
             <a:ext cx="4679004" cy="719401"/>
           </a:xfrm>
           <a:prstGeom prst="rect">
@@ -4033,8 +4033,8 @@
         </p:nvSpPr>
         <p:spPr>
           <a:xfrm>
-            <a:off x="19378353" y="38784221"/>
-            <a:ext cx="9570397" cy="2269464"/>
+            <a:off x="19378353" y="38784212"/>
+            <a:ext cx="9519789" cy="3190000"/>
           </a:xfrm>
           <a:prstGeom prst="roundRect">
             <a:avLst>
@@ -7384,7 +7384,7 @@
         </p:nvSpPr>
         <p:spPr>
           <a:xfrm>
-            <a:off x="1058151" y="38947408"/>
+            <a:off x="1058151" y="38983412"/>
             <a:ext cx="17381508" cy="528876"/>
           </a:xfrm>
           <a:prstGeom prst="rect">
@@ -7418,7 +7418,7 @@
         </p:nvSpPr>
         <p:spPr>
           <a:xfrm>
-            <a:off x="1058151" y="39463547"/>
+            <a:off x="1058151" y="39499551"/>
             <a:ext cx="13065356" cy="528876"/>
           </a:xfrm>
           <a:prstGeom prst="rect">
@@ -7470,7 +7470,7 @@
         </p:nvSpPr>
         <p:spPr>
           <a:xfrm>
-            <a:off x="9571444" y="40417951"/>
+            <a:off x="9571444" y="40453955"/>
             <a:ext cx="5553286" cy="312517"/>
           </a:xfrm>
           <a:prstGeom prst="rect">
@@ -7522,7 +7522,7 @@
         </p:nvSpPr>
         <p:spPr>
           <a:xfrm>
-            <a:off x="9571444" y="40822829"/>
+            <a:off x="9571444" y="40858833"/>
             <a:ext cx="5338896" cy="312517"/>
           </a:xfrm>
           <a:prstGeom prst="rect">
@@ -7565,8 +7565,8 @@
         </p:nvSpPr>
         <p:spPr>
           <a:xfrm>
-            <a:off x="19555245" y="38950658"/>
-            <a:ext cx="9110214" cy="312774"/>
+            <a:off x="19529945" y="38926172"/>
+            <a:ext cx="7730294" cy="288714"/>
           </a:xfrm>
           <a:prstGeom prst="rect">
             <a:avLst/>
@@ -7580,16 +7580,16 @@
           <a:lstStyle/>
           <a:p>
             <a:r>
-              <a:rPr sz="2460" b="1" i="0">
-                <a:solidFill>
-                  <a:srgbClr val="0B0B0B"/>
-                </a:solidFill>
-                <a:latin typeface="Arial"/>
-              </a:rPr>
-              <a:t>Neural</a:t>
-            </a:r>
-            <a:r>
-              <a:rPr sz="2460" b="1" i="0">
+              <a:rPr sz="2270" b="1" i="0">
+                <a:solidFill>
+                  <a:srgbClr val="0B0B0B"/>
+                </a:solidFill>
+                <a:latin typeface="Arial"/>
+              </a:rPr>
+              <a:t>Two</a:t>
+            </a:r>
+            <a:r>
+              <a:rPr sz="2270" b="1" i="0">
                 <a:solidFill>
                   <a:srgbClr val="0B0B0B"/>
                 </a:solidFill>
@@ -7598,16 +7598,52 @@
               <a:t> </a:t>
             </a:r>
             <a:r>
-              <a:rPr sz="2460" b="1" i="0">
-                <a:solidFill>
-                  <a:srgbClr val="0B0B0B"/>
-                </a:solidFill>
-                <a:latin typeface="Arial"/>
-              </a:rPr>
-              <a:t>baseline</a:t>
-            </a:r>
-            <a:r>
-              <a:rPr sz="2460" b="0" i="0">
+              <a:rPr sz="2270" b="1" i="0">
+                <a:solidFill>
+                  <a:srgbClr val="0B0B0B"/>
+                </a:solidFill>
+                <a:latin typeface="Arial"/>
+              </a:rPr>
+              <a:t>approaches</a:t>
+            </a:r>
+            <a:r>
+              <a:rPr sz="2270" b="1" i="0">
+                <a:solidFill>
+                  <a:srgbClr val="0B0B0B"/>
+                </a:solidFill>
+                <a:latin typeface="Arial"/>
+              </a:rPr>
+              <a:t> </a:t>
+            </a:r>
+            <a:r>
+              <a:rPr sz="2270" b="1" i="0">
+                <a:solidFill>
+                  <a:srgbClr val="0B0B0B"/>
+                </a:solidFill>
+                <a:latin typeface="Arial"/>
+              </a:rPr>
+              <a:t>to</a:t>
+            </a:r>
+            <a:r>
+              <a:rPr sz="2270" b="1" i="0">
+                <a:solidFill>
+                  <a:srgbClr val="0B0B0B"/>
+                </a:solidFill>
+                <a:latin typeface="Arial"/>
+              </a:rPr>
+              <a:t> </a:t>
+            </a:r>
+            <a:r>
+              <a:rPr sz="2270" b="1" i="0">
+                <a:solidFill>
+                  <a:srgbClr val="0B0B0B"/>
+                </a:solidFill>
+                <a:latin typeface="Arial"/>
+              </a:rPr>
+              <a:t>ARC</a:t>
+            </a:r>
+            <a:r>
+              <a:rPr sz="2270" b="0" i="0">
                 <a:solidFill>
                   <a:srgbClr val="0B0B0B"/>
                 </a:solidFill>
@@ -7616,7 +7652,7 @@
               <a:t>,</a:t>
             </a:r>
             <a:r>
-              <a:rPr sz="2460" b="0" i="0">
+              <a:rPr sz="2270" b="0" i="0">
                 <a:solidFill>
                   <a:srgbClr val="0B0B0B"/>
                 </a:solidFill>
@@ -7625,7 +7661,7 @@
               <a:t> </a:t>
             </a:r>
             <a:r>
-              <a:rPr sz="2460" b="0" i="0">
+              <a:rPr sz="2270" b="0" i="0">
                 <a:solidFill>
                   <a:srgbClr val="0B0B0B"/>
                 </a:solidFill>
@@ -7634,7 +7670,7 @@
               <a:t>official</a:t>
             </a:r>
             <a:r>
-              <a:rPr sz="2460" b="0" i="0">
+              <a:rPr sz="2270" b="0" i="0">
                 <a:solidFill>
                   <a:srgbClr val="0B0B0B"/>
                 </a:solidFill>
@@ -7643,7 +7679,7 @@
               <a:t> </a:t>
             </a:r>
             <a:r>
-              <a:rPr sz="2460" b="0" i="0">
+              <a:rPr sz="2270" b="0" i="0">
                 <a:solidFill>
                   <a:srgbClr val="0B0B0B"/>
                 </a:solidFill>
@@ -7652,7 +7688,7 @@
               <a:t>public</a:t>
             </a:r>
             <a:r>
-              <a:rPr sz="2460" b="0" i="0">
+              <a:rPr sz="2270" b="0" i="0">
                 <a:solidFill>
                   <a:srgbClr val="0B0B0B"/>
                 </a:solidFill>
@@ -7661,16 +7697,16 @@
               <a:t> </a:t>
             </a:r>
             <a:r>
-              <a:rPr sz="2460" b="0" i="0">
-                <a:solidFill>
-                  <a:srgbClr val="0B0B0B"/>
-                </a:solidFill>
-                <a:latin typeface="Arial"/>
-              </a:rPr>
-              <a:t>ARC-AGI-2:</a:t>
-            </a:r>
-            <a:r>
-              <a:rPr sz="2460" b="0" i="0">
+              <a:rPr sz="2270" b="0" i="0">
+                <a:solidFill>
+                  <a:srgbClr val="0B0B0B"/>
+                </a:solidFill>
+                <a:latin typeface="Arial"/>
+              </a:rPr>
+              <a:t>ARC-AGI-2</a:t>
+            </a:r>
+            <a:r>
+              <a:rPr sz="2270" b="0" i="0">
                 <a:solidFill>
                   <a:srgbClr val="0B0B0B"/>
                 </a:solidFill>
@@ -7679,49 +7715,13 @@
               <a:t> </a:t>
             </a:r>
             <a:r>
-              <a:rPr sz="2460" b="0" i="0">
-                <a:solidFill>
-                  <a:srgbClr val="0B0B0B"/>
-                </a:solidFill>
-                <a:latin typeface="Arial"/>
-              </a:rPr>
-              <a:t>native</a:t>
-            </a:r>
-            <a:r>
-              <a:rPr sz="2460" b="0" i="0">
-                <a:solidFill>
-                  <a:srgbClr val="0B0B0B"/>
-                </a:solidFill>
-                <a:latin typeface="Arial"/>
-              </a:rPr>
-              <a:t> </a:t>
-            </a:r>
-            <a:r>
-              <a:rPr sz="2460" b="0" i="0">
-                <a:solidFill>
-                  <a:srgbClr val="0B0B0B"/>
-                </a:solidFill>
-                <a:latin typeface="Arial"/>
-              </a:rPr>
-              <a:t>CORA</a:t>
-            </a:r>
-            <a:r>
-              <a:rPr sz="2460" b="1" i="0">
-                <a:solidFill>
-                  <a:srgbClr val="0B0B0B"/>
-                </a:solidFill>
-                <a:latin typeface="Arial"/>
-              </a:rPr>
-              <a:t> </a:t>
-            </a:r>
-            <a:r>
-              <a:rPr sz="2460" b="1" i="0">
-                <a:solidFill>
-                  <a:srgbClr val="0B0B0B"/>
-                </a:solidFill>
-                <a:latin typeface="Arial"/>
-              </a:rPr>
-              <a:t>0.00%</a:t>
+              <a:rPr sz="2270" b="0" i="0">
+                <a:solidFill>
+                  <a:srgbClr val="0B0B0B"/>
+                </a:solidFill>
+                <a:latin typeface="Arial"/>
+              </a:rPr>
+              <a:t>scores</a:t>
             </a:r>
           </a:p>
         </p:txBody>
@@ -7734,8 +7734,8 @@
         </p:nvSpPr>
         <p:spPr>
           <a:xfrm>
-            <a:off x="19555243" y="39345982"/>
-            <a:ext cx="8424236" cy="322324"/>
+            <a:off x="19529945" y="39314332"/>
+            <a:ext cx="3906868" cy="288475"/>
           </a:xfrm>
           <a:prstGeom prst="rect">
             <a:avLst/>
@@ -7749,16 +7749,16 @@
           <a:lstStyle/>
           <a:p>
             <a:r>
-              <a:rPr sz="2480" b="0" i="1">
-                <a:solidFill>
-                  <a:srgbClr val="0B0B0B"/>
-                </a:solidFill>
-                <a:latin typeface="Arial"/>
-              </a:rPr>
-              <a:t>·</a:t>
-            </a:r>
-            <a:r>
-              <a:rPr sz="2460" b="0" i="0">
+              <a:rPr sz="2270" b="1" i="0">
+                <a:solidFill>
+                  <a:srgbClr val="0B0B0B"/>
+                </a:solidFill>
+                <a:latin typeface="Arial"/>
+              </a:rPr>
+              <a:t>NVARC</a:t>
+            </a:r>
+            <a:r>
+              <a:rPr sz="2270" b="1" i="0">
                 <a:solidFill>
                   <a:srgbClr val="0B0B0B"/>
                 </a:solidFill>
@@ -7767,16 +7767,16 @@
               <a:t> </a:t>
             </a:r>
             <a:r>
-              <a:rPr sz="2460" b="0" i="0">
-                <a:solidFill>
-                  <a:srgbClr val="0B0B0B"/>
-                </a:solidFill>
-                <a:latin typeface="Arial"/>
-              </a:rPr>
-              <a:t>CORA</a:t>
-            </a:r>
-            <a:r>
-              <a:rPr sz="2460" b="0" i="0">
+              <a:rPr sz="2270" b="1" i="0">
+                <a:solidFill>
+                  <a:srgbClr val="0B0B0B"/>
+                </a:solidFill>
+                <a:latin typeface="Arial"/>
+              </a:rPr>
+              <a:t>/</a:t>
+            </a:r>
+            <a:r>
+              <a:rPr sz="2270" b="1" i="0">
                 <a:solidFill>
                   <a:srgbClr val="0B0B0B"/>
                 </a:solidFill>
@@ -7785,16 +7785,16 @@
               <a:t> </a:t>
             </a:r>
             <a:r>
-              <a:rPr sz="2460" b="0" i="0">
-                <a:solidFill>
-                  <a:srgbClr val="0B0B0B"/>
-                </a:solidFill>
-                <a:latin typeface="Arial"/>
-              </a:rPr>
-              <a:t>with</a:t>
-            </a:r>
-            <a:r>
-              <a:rPr sz="2460" b="0" i="0">
+              <a:rPr sz="2270" b="1" i="0">
+                <a:solidFill>
+                  <a:srgbClr val="0B0B0B"/>
+                </a:solidFill>
+                <a:latin typeface="Arial"/>
+              </a:rPr>
+              <a:t>Qwen3-4B:</a:t>
+            </a:r>
+            <a:r>
+              <a:rPr sz="2270" b="1" i="0">
                 <a:solidFill>
                   <a:srgbClr val="0B0B0B"/>
                 </a:solidFill>
@@ -7803,103 +7803,13 @@
               <a:t> </a:t>
             </a:r>
             <a:r>
-              <a:rPr sz="2460" b="0" i="0">
-                <a:solidFill>
-                  <a:srgbClr val="0B0B0B"/>
-                </a:solidFill>
-                <a:latin typeface="Arial"/>
-              </a:rPr>
-              <a:t>rule</a:t>
-            </a:r>
-            <a:r>
-              <a:rPr sz="2460" b="0" i="0">
-                <a:solidFill>
-                  <a:srgbClr val="0B0B0B"/>
-                </a:solidFill>
-                <a:latin typeface="Arial"/>
-              </a:rPr>
-              <a:t> </a:t>
-            </a:r>
-            <a:r>
-              <a:rPr sz="2460" b="0" i="0">
-                <a:solidFill>
-                  <a:srgbClr val="0B0B0B"/>
-                </a:solidFill>
-                <a:latin typeface="Arial"/>
-              </a:rPr>
-              <a:t>construction</a:t>
-            </a:r>
-            <a:r>
-              <a:rPr sz="2460" b="1" i="0">
-                <a:solidFill>
-                  <a:srgbClr val="0B0B0B"/>
-                </a:solidFill>
-                <a:latin typeface="Arial"/>
-              </a:rPr>
-              <a:t> </a:t>
-            </a:r>
-            <a:r>
-              <a:rPr sz="2460" b="1" i="0">
-                <a:solidFill>
-                  <a:srgbClr val="0B0B0B"/>
-                </a:solidFill>
-                <a:latin typeface="Arial"/>
-              </a:rPr>
-              <a:t>0.00%</a:t>
-            </a:r>
-            <a:r>
-              <a:rPr sz="2480" b="0" i="1">
-                <a:solidFill>
-                  <a:srgbClr val="0B0B0B"/>
-                </a:solidFill>
-                <a:latin typeface="Arial"/>
-              </a:rPr>
-              <a:t> </a:t>
-            </a:r>
-            <a:r>
-              <a:rPr sz="2480" b="0" i="1">
-                <a:solidFill>
-                  <a:srgbClr val="0B0B0B"/>
-                </a:solidFill>
-                <a:latin typeface="Arial"/>
-              </a:rPr>
-              <a:t>·</a:t>
-            </a:r>
-            <a:r>
-              <a:rPr sz="2460" b="0" i="0">
-                <a:solidFill>
-                  <a:srgbClr val="0B0B0B"/>
-                </a:solidFill>
-                <a:latin typeface="Arial"/>
-              </a:rPr>
-              <a:t> </a:t>
-            </a:r>
-            <a:r>
-              <a:rPr sz="2460" b="0" i="0">
-                <a:solidFill>
-                  <a:srgbClr val="0B0B0B"/>
-                </a:solidFill>
-                <a:latin typeface="Arial"/>
-              </a:rPr>
-              <a:t>NVARC</a:t>
-            </a:r>
-            <a:r>
-              <a:rPr sz="2460" b="0" i="0">
-                <a:solidFill>
-                  <a:srgbClr val="0B0B0B"/>
-                </a:solidFill>
-                <a:latin typeface="Arial"/>
-              </a:rPr>
-              <a:t> </a:t>
-            </a:r>
-            <a:r>
-              <a:rPr sz="2460" b="0" i="0">
-                <a:solidFill>
-                  <a:srgbClr val="0B0B0B"/>
-                </a:solidFill>
-                <a:latin typeface="Arial"/>
-              </a:rPr>
-              <a:t>reproduction</a:t>
+              <a:rPr sz="2270" b="1" i="0">
+                <a:solidFill>
+                  <a:srgbClr val="0B0B0B"/>
+                </a:solidFill>
+                <a:latin typeface="Arial"/>
+              </a:rPr>
+              <a:t>27.64%</a:t>
             </a:r>
           </a:p>
         </p:txBody>
@@ -7912,8 +7822,8 @@
         </p:nvSpPr>
         <p:spPr>
           <a:xfrm>
-            <a:off x="19555245" y="39760422"/>
-            <a:ext cx="9021453" cy="312774"/>
+            <a:off x="24073742" y="39314093"/>
+            <a:ext cx="4154565" cy="288714"/>
           </a:xfrm>
           <a:prstGeom prst="rect">
             <a:avLst/>
@@ -7927,25 +7837,16 @@
           <a:lstStyle/>
           <a:p>
             <a:r>
-              <a:rPr sz="2460" b="1" i="0">
-                <a:solidFill>
-                  <a:srgbClr val="0B0B0B"/>
-                </a:solidFill>
-                <a:latin typeface="Arial"/>
-              </a:rPr>
-              <a:t>27.64%</a:t>
-            </a:r>
-            <a:r>
-              <a:rPr sz="2460" b="0" i="0">
-                <a:solidFill>
-                  <a:srgbClr val="0B0B0B"/>
-                </a:solidFill>
-                <a:latin typeface="Arial"/>
-              </a:rPr>
-              <a:t>,</a:t>
-            </a:r>
-            <a:r>
-              <a:rPr sz="2460" b="0" i="0">
+              <a:rPr sz="2270" b="1" i="0">
+                <a:solidFill>
+                  <a:srgbClr val="0B0B0B"/>
+                </a:solidFill>
+                <a:latin typeface="Arial"/>
+              </a:rPr>
+              <a:t>CORA:</a:t>
+            </a:r>
+            <a:r>
+              <a:rPr sz="2270" b="1" i="0">
                 <a:solidFill>
                   <a:srgbClr val="0B0B0B"/>
                 </a:solidFill>
@@ -7954,16 +7855,16 @@
               <a:t> </a:t>
             </a:r>
             <a:r>
-              <a:rPr sz="2460" b="0" i="0">
-                <a:solidFill>
-                  <a:srgbClr val="0B0B0B"/>
-                </a:solidFill>
-                <a:latin typeface="Arial"/>
-              </a:rPr>
-              <a:t>a</a:t>
-            </a:r>
-            <a:r>
-              <a:rPr sz="2460" b="0" i="0">
+              <a:rPr sz="2270" b="1" i="0">
+                <a:solidFill>
+                  <a:srgbClr val="0B0B0B"/>
+                </a:solidFill>
+                <a:latin typeface="Arial"/>
+              </a:rPr>
+              <a:t>0.00%</a:t>
+            </a:r>
+            <a:r>
+              <a:rPr sz="2270" b="0" i="0">
                 <a:solidFill>
                   <a:srgbClr val="0B0B0B"/>
                 </a:solidFill>
@@ -7972,16 +7873,16 @@
               <a:t> </a:t>
             </a:r>
             <a:r>
-              <a:rPr sz="2460" b="0" i="0">
-                <a:solidFill>
-                  <a:srgbClr val="0B0B0B"/>
-                </a:solidFill>
-                <a:latin typeface="Arial"/>
-              </a:rPr>
-              <a:t>third-party</a:t>
-            </a:r>
-            <a:r>
-              <a:rPr sz="2460" b="0" i="0">
+              <a:rPr sz="2270" b="0" i="0">
+                <a:solidFill>
+                  <a:srgbClr val="0B0B0B"/>
+                </a:solidFill>
+                <a:latin typeface="Arial"/>
+              </a:rPr>
+              <a:t>(also</a:t>
+            </a:r>
+            <a:r>
+              <a:rPr sz="2270" b="0" i="0">
                 <a:solidFill>
                   <a:srgbClr val="0B0B0B"/>
                 </a:solidFill>
@@ -7990,16 +7891,16 @@
               <a:t> </a:t>
             </a:r>
             <a:r>
-              <a:rPr sz="2460" b="0" i="0">
-                <a:solidFill>
-                  <a:srgbClr val="0B0B0B"/>
-                </a:solidFill>
-                <a:latin typeface="Arial"/>
-              </a:rPr>
-              <a:t>Qwen3-4B</a:t>
-            </a:r>
-            <a:r>
-              <a:rPr sz="2460" b="0" i="0">
+              <a:rPr sz="2270" b="0" i="0">
+                <a:solidFill>
+                  <a:srgbClr val="0B0B0B"/>
+                </a:solidFill>
+                <a:latin typeface="Arial"/>
+              </a:rPr>
+              <a:t>0.00%</a:t>
+            </a:r>
+            <a:r>
+              <a:rPr sz="2270" b="0" i="0">
                 <a:solidFill>
                   <a:srgbClr val="0B0B0B"/>
                 </a:solidFill>
@@ -8008,94 +7909,13 @@
               <a:t> </a:t>
             </a:r>
             <a:r>
-              <a:rPr sz="2460" b="0" i="0">
-                <a:solidFill>
-                  <a:srgbClr val="0B0B0B"/>
-                </a:solidFill>
-                <a:latin typeface="Arial"/>
-              </a:rPr>
-              <a:t>method,</a:t>
-            </a:r>
-            <a:r>
-              <a:rPr sz="2460" b="1" i="0">
-                <a:solidFill>
-                  <a:srgbClr val="0B0B0B"/>
-                </a:solidFill>
-                <a:latin typeface="Arial"/>
-              </a:rPr>
-              <a:t> </a:t>
-            </a:r>
-            <a:r>
-              <a:rPr sz="2460" b="1" i="0">
-                <a:solidFill>
-                  <a:srgbClr val="0B0B0B"/>
-                </a:solidFill>
-                <a:latin typeface="Arial"/>
-              </a:rPr>
-              <a:t>not</a:t>
-            </a:r>
-            <a:r>
-              <a:rPr sz="2460" b="1" i="0">
-                <a:solidFill>
-                  <a:srgbClr val="0B0B0B"/>
-                </a:solidFill>
-                <a:latin typeface="Arial"/>
-              </a:rPr>
-              <a:t> </a:t>
-            </a:r>
-            <a:r>
-              <a:rPr sz="2460" b="1" i="0">
-                <a:solidFill>
-                  <a:srgbClr val="0B0B0B"/>
-                </a:solidFill>
-                <a:latin typeface="Arial"/>
-              </a:rPr>
-              <a:t>CORA</a:t>
-            </a:r>
-            <a:r>
-              <a:rPr sz="2460" b="0" i="0">
-                <a:solidFill>
-                  <a:srgbClr val="0B0B0B"/>
-                </a:solidFill>
-                <a:latin typeface="Arial"/>
-              </a:rPr>
-              <a:t>:</a:t>
-            </a:r>
-            <a:r>
-              <a:rPr sz="2460" b="0" i="0">
-                <a:solidFill>
-                  <a:srgbClr val="0B0B0B"/>
-                </a:solidFill>
-                <a:latin typeface="Arial"/>
-              </a:rPr>
-              <a:t> </a:t>
-            </a:r>
-            <a:r>
-              <a:rPr sz="2460" b="0" i="0">
-                <a:solidFill>
-                  <a:srgbClr val="0B0B0B"/>
-                </a:solidFill>
-                <a:latin typeface="Arial"/>
-              </a:rPr>
-              <a:t>a</a:t>
-            </a:r>
-            <a:r>
-              <a:rPr sz="2460" b="0" i="0">
-                <a:solidFill>
-                  <a:srgbClr val="0B0B0B"/>
-                </a:solidFill>
-                <a:latin typeface="Arial"/>
-              </a:rPr>
-              <a:t> </a:t>
-            </a:r>
-            <a:r>
-              <a:rPr sz="2460" b="0" i="0">
-                <a:solidFill>
-                  <a:srgbClr val="0B0B0B"/>
-                </a:solidFill>
-                <a:latin typeface="Arial"/>
-              </a:rPr>
-              <a:t>compet-</a:t>
+              <a:rPr sz="2270" b="0" i="0">
+                <a:solidFill>
+                  <a:srgbClr val="0B0B0B"/>
+                </a:solidFill>
+                <a:latin typeface="Arial"/>
+              </a:rPr>
+              <a:t>with</a:t>
             </a:r>
           </a:p>
         </p:txBody>
@@ -8108,8 +7928,8 @@
         </p:nvSpPr>
         <p:spPr>
           <a:xfrm>
-            <a:off x="19555245" y="40165297"/>
-            <a:ext cx="8791908" cy="312517"/>
+            <a:off x="24073775" y="39681010"/>
+            <a:ext cx="2287647" cy="288475"/>
           </a:xfrm>
           <a:prstGeom prst="rect">
             <a:avLst/>
@@ -8123,16 +7943,16 @@
           <a:lstStyle/>
           <a:p>
             <a:r>
-              <a:rPr sz="2460" b="0" i="0">
-                <a:solidFill>
-                  <a:srgbClr val="0B0B0B"/>
-                </a:solidFill>
-                <a:latin typeface="Arial"/>
-              </a:rPr>
-              <a:t>itive</a:t>
-            </a:r>
-            <a:r>
-              <a:rPr sz="2460" b="0" i="0">
+              <a:rPr sz="2270" b="0" i="0">
+                <a:solidFill>
+                  <a:srgbClr val="0B0B0B"/>
+                </a:solidFill>
+                <a:latin typeface="Arial"/>
+              </a:rPr>
+              <a:t>rule</a:t>
+            </a:r>
+            <a:r>
+              <a:rPr sz="2270" b="0" i="0">
                 <a:solidFill>
                   <a:srgbClr val="0B0B0B"/>
                 </a:solidFill>
@@ -8141,139 +7961,13 @@
               <a:t> </a:t>
             </a:r>
             <a:r>
-              <a:rPr sz="2460" b="0" i="0">
-                <a:solidFill>
-                  <a:srgbClr val="0B0B0B"/>
-                </a:solidFill>
-                <a:latin typeface="Arial"/>
-              </a:rPr>
-              <a:t>baseline.</a:t>
-            </a:r>
-            <a:r>
-              <a:rPr sz="2460" b="0" i="0">
-                <a:solidFill>
-                  <a:srgbClr val="0B0B0B"/>
-                </a:solidFill>
-                <a:latin typeface="Arial"/>
-              </a:rPr>
-              <a:t> </a:t>
-            </a:r>
-            <a:r>
-              <a:rPr sz="2460" b="0" i="0">
-                <a:solidFill>
-                  <a:srgbClr val="0B0B0B"/>
-                </a:solidFill>
-                <a:latin typeface="Arial"/>
-              </a:rPr>
-              <a:t>CORA</a:t>
-            </a:r>
-            <a:r>
-              <a:rPr sz="2460" b="0" i="0">
-                <a:solidFill>
-                  <a:srgbClr val="0B0B0B"/>
-                </a:solidFill>
-                <a:latin typeface="Arial"/>
-              </a:rPr>
-              <a:t> </a:t>
-            </a:r>
-            <a:r>
-              <a:rPr sz="2460" b="0" i="0">
-                <a:solidFill>
-                  <a:srgbClr val="0B0B0B"/>
-                </a:solidFill>
-                <a:latin typeface="Arial"/>
-              </a:rPr>
-              <a:t>asks</a:t>
-            </a:r>
-            <a:r>
-              <a:rPr sz="2460" b="0" i="0">
-                <a:solidFill>
-                  <a:srgbClr val="0B0B0B"/>
-                </a:solidFill>
-                <a:latin typeface="Arial"/>
-              </a:rPr>
-              <a:t> </a:t>
-            </a:r>
-            <a:r>
-              <a:rPr sz="2460" b="0" i="0">
-                <a:solidFill>
-                  <a:srgbClr val="0B0B0B"/>
-                </a:solidFill>
-                <a:latin typeface="Arial"/>
-              </a:rPr>
-              <a:t>whether</a:t>
-            </a:r>
-            <a:r>
-              <a:rPr sz="2460" b="0" i="0">
-                <a:solidFill>
-                  <a:srgbClr val="0B0B0B"/>
-                </a:solidFill>
-                <a:latin typeface="Arial"/>
-              </a:rPr>
-              <a:t> </a:t>
-            </a:r>
-            <a:r>
-              <a:rPr sz="2460" b="0" i="0">
-                <a:solidFill>
-                  <a:srgbClr val="0B0B0B"/>
-                </a:solidFill>
-                <a:latin typeface="Arial"/>
-              </a:rPr>
-              <a:t>executable</a:t>
-            </a:r>
-            <a:r>
-              <a:rPr sz="2460" b="0" i="0">
-                <a:solidFill>
-                  <a:srgbClr val="0B0B0B"/>
-                </a:solidFill>
-                <a:latin typeface="Arial"/>
-              </a:rPr>
-              <a:t> </a:t>
-            </a:r>
-            <a:r>
-              <a:rPr sz="2460" b="0" i="0">
-                <a:solidFill>
-                  <a:srgbClr val="0B0B0B"/>
-                </a:solidFill>
-                <a:latin typeface="Arial"/>
-              </a:rPr>
-              <a:t>revision</a:t>
-            </a:r>
-            <a:r>
-              <a:rPr sz="2460" b="0" i="0">
-                <a:solidFill>
-                  <a:srgbClr val="0B0B0B"/>
-                </a:solidFill>
-                <a:latin typeface="Arial"/>
-              </a:rPr>
-              <a:t> </a:t>
-            </a:r>
-            <a:r>
-              <a:rPr sz="2460" b="0" i="0">
-                <a:solidFill>
-                  <a:srgbClr val="0B0B0B"/>
-                </a:solidFill>
-                <a:latin typeface="Arial"/>
-              </a:rPr>
-              <a:t>adds</a:t>
-            </a:r>
-            <a:r>
-              <a:rPr sz="2460" b="0" i="0">
-                <a:solidFill>
-                  <a:srgbClr val="0B0B0B"/>
-                </a:solidFill>
-                <a:latin typeface="Arial"/>
-              </a:rPr>
-              <a:t> </a:t>
-            </a:r>
-            <a:r>
-              <a:rPr sz="2460" b="0" i="0">
-                <a:solidFill>
-                  <a:srgbClr val="0B0B0B"/>
-                </a:solidFill>
-                <a:latin typeface="Arial"/>
-              </a:rPr>
-              <a:t>a</a:t>
+              <a:rPr sz="2270" b="0" i="0">
+                <a:solidFill>
+                  <a:srgbClr val="0B0B0B"/>
+                </a:solidFill>
+                <a:latin typeface="Arial"/>
+              </a:rPr>
+              <a:t>construction)</a:t>
             </a:r>
           </a:p>
         </p:txBody>
@@ -8286,8 +7980,8 @@
         </p:nvSpPr>
         <p:spPr>
           <a:xfrm>
-            <a:off x="19555245" y="40570187"/>
-            <a:ext cx="2725949" cy="312517"/>
+            <a:off x="19529944" y="40047936"/>
+            <a:ext cx="4054281" cy="288475"/>
           </a:xfrm>
           <a:prstGeom prst="rect">
             <a:avLst/>
@@ -8301,16 +7995,16 @@
           <a:lstStyle/>
           <a:p>
             <a:r>
-              <a:rPr sz="2460" b="0" i="0">
-                <a:solidFill>
-                  <a:srgbClr val="0B0B0B"/>
-                </a:solidFill>
-                <a:latin typeface="Arial"/>
-              </a:rPr>
-              <a:t>separate</a:t>
-            </a:r>
-            <a:r>
-              <a:rPr sz="2460" b="0" i="0">
+              <a:rPr sz="2270" b="0" i="0">
+                <a:solidFill>
+                  <a:srgbClr val="0B0B0B"/>
+                </a:solidFill>
+                <a:latin typeface="Arial"/>
+              </a:rPr>
+              <a:t>reproduced</a:t>
+            </a:r>
+            <a:r>
+              <a:rPr sz="2270" b="0" i="0">
                 <a:solidFill>
                   <a:srgbClr val="0B0B0B"/>
                 </a:solidFill>
@@ -8319,13 +8013,31 @@
               <a:t> </a:t>
             </a:r>
             <a:r>
-              <a:rPr sz="2460" b="0" i="0">
-                <a:solidFill>
-                  <a:srgbClr val="0B0B0B"/>
-                </a:solidFill>
-                <a:latin typeface="Arial"/>
-              </a:rPr>
-              <a:t>capability.</a:t>
+              <a:rPr sz="2270" b="0" i="0">
+                <a:solidFill>
+                  <a:srgbClr val="0B0B0B"/>
+                </a:solidFill>
+                <a:latin typeface="Arial"/>
+              </a:rPr>
+              <a:t>third-party</a:t>
+            </a:r>
+            <a:r>
+              <a:rPr sz="2270" b="0" i="0">
+                <a:solidFill>
+                  <a:srgbClr val="0B0B0B"/>
+                </a:solidFill>
+                <a:latin typeface="Arial"/>
+              </a:rPr>
+              <a:t> </a:t>
+            </a:r>
+            <a:r>
+              <a:rPr sz="2270" b="0" i="0">
+                <a:solidFill>
+                  <a:srgbClr val="0B0B0B"/>
+                </a:solidFill>
+                <a:latin typeface="Arial"/>
+              </a:rPr>
+              <a:t>method,</a:t>
             </a:r>
           </a:p>
         </p:txBody>
@@ -8338,8 +8050,8 @@
         </p:nvSpPr>
         <p:spPr>
           <a:xfrm>
-            <a:off x="936003" y="41490007"/>
-            <a:ext cx="28454909" cy="264439"/>
+            <a:off x="19529944" y="40414866"/>
+            <a:ext cx="4036480" cy="288714"/>
           </a:xfrm>
           <a:prstGeom prst="rect">
             <a:avLst/>
@@ -8353,49 +8065,94 @@
           <a:lstStyle/>
           <a:p>
             <a:r>
-              <a:rPr sz="2080" b="0" i="0">
-                <a:solidFill>
-                  <a:srgbClr val="52514E"/>
-                </a:solidFill>
-                <a:latin typeface="Arial"/>
-              </a:rPr>
-              <a:t>Related work:</a:t>
-            </a:r>
-            <a:r>
-              <a:rPr sz="2080" b="0" i="0">
-                <a:solidFill>
-                  <a:srgbClr val="52514E"/>
+              <a:rPr sz="2270" b="1" i="0">
+                <a:solidFill>
+                  <a:srgbClr val="0B0B0B"/>
+                </a:solidFill>
+                <a:latin typeface="Arial"/>
+              </a:rPr>
+              <a:t>not</a:t>
+            </a:r>
+            <a:r>
+              <a:rPr sz="2270" b="1" i="0">
+                <a:solidFill>
+                  <a:srgbClr val="0B0B0B"/>
                 </a:solidFill>
                 <a:latin typeface="Arial"/>
               </a:rPr>
               <a:t> </a:t>
             </a:r>
             <a:r>
-              <a:rPr sz="2080" b="0" i="0">
-                <a:solidFill>
-                  <a:srgbClr val="52514E"/>
-                </a:solidFill>
-                <a:latin typeface="Arial"/>
-              </a:rPr>
-              <a:t>Popper (Cropper &amp; Morel 2021); DreamCoder (Ellis et al. 2021); LILO (Grand et al. 2024); Model Discovery Agent (Murphy 2026).</a:t>
-            </a:r>
-            <a:r>
-              <a:rPr sz="2080" b="0" i="0">
-                <a:solidFill>
-                  <a:srgbClr val="52514E"/>
+              <a:rPr sz="2270" b="1" i="0">
+                <a:solidFill>
+                  <a:srgbClr val="0B0B0B"/>
+                </a:solidFill>
+                <a:latin typeface="Arial"/>
+              </a:rPr>
+              <a:t>CORA</a:t>
+            </a:r>
+            <a:r>
+              <a:rPr sz="2270" b="0" i="0">
+                <a:solidFill>
+                  <a:srgbClr val="0B0B0B"/>
+                </a:solidFill>
+                <a:latin typeface="Arial"/>
+              </a:rPr>
+              <a:t>;</a:t>
+            </a:r>
+            <a:r>
+              <a:rPr sz="2270" b="0" i="0">
+                <a:solidFill>
+                  <a:srgbClr val="0B0B0B"/>
                 </a:solidFill>
                 <a:latin typeface="Arial"/>
               </a:rPr>
               <a:t> </a:t>
             </a:r>
             <a:r>
-              <a:rPr sz="2080" b="0" i="0">
-                <a:solidFill>
-                  <a:srgbClr val="52514E"/>
-                </a:solidFill>
-                <a:latin typeface="Arial"/>
-              </a:rPr>
-              <a:t>The failure-to-revision idea is not new; the question is which component to revise, against matched</a:t>
+              <a:rPr sz="2270" b="0" i="0">
+                <a:solidFill>
+                  <a:srgbClr val="0B0B0B"/>
+                </a:solidFill>
+                <a:latin typeface="Arial"/>
+              </a:rPr>
+              <a:t>neural</a:t>
+            </a:r>
+            <a:r>
+              <a:rPr sz="2270" b="0" i="0">
+                <a:solidFill>
+                  <a:srgbClr val="0B0B0B"/>
+                </a:solidFill>
+                <a:latin typeface="Arial"/>
+              </a:rPr>
+              <a:t> </a:t>
+            </a:r>
+            <a:r>
+              <a:rPr sz="2270" b="0" i="0">
+                <a:solidFill>
+                  <a:srgbClr val="0B0B0B"/>
+                </a:solidFill>
+                <a:latin typeface="Arial"/>
+              </a:rPr>
+              <a:t>training</a:t>
+            </a:r>
+            <a:r>
+              <a:rPr sz="2270" b="0" i="0">
+                <a:solidFill>
+                  <a:srgbClr val="0B0B0B"/>
+                </a:solidFill>
+                <a:latin typeface="Arial"/>
+              </a:rPr>
+              <a:t> </a:t>
+            </a:r>
+            <a:r>
+              <a:rPr sz="2270" b="0" i="0">
+                <a:solidFill>
+                  <a:srgbClr val="0B0B0B"/>
+                </a:solidFill>
+                <a:latin typeface="Arial"/>
+              </a:rPr>
+              <a:t>and</a:t>
             </a:r>
           </a:p>
         </p:txBody>
@@ -8408,7 +8165,643 @@
         </p:nvSpPr>
         <p:spPr>
           <a:xfrm>
-            <a:off x="936003" y="41826684"/>
+            <a:off x="19529944" y="40781780"/>
+            <a:ext cx="2536028" cy="288475"/>
+          </a:xfrm>
+          <a:prstGeom prst="rect">
+            <a:avLst/>
+          </a:prstGeom>
+          <a:noFill/>
+        </p:spPr>
+        <p:txBody>
+          <a:bodyPr wrap="none" lIns="0" rIns="0" tIns="0" bIns="0">
+            <a:spAutoFit/>
+          </a:bodyPr>
+          <a:lstStyle/>
+          <a:p>
+            <a:r>
+              <a:rPr sz="2270" b="0" i="0">
+                <a:solidFill>
+                  <a:srgbClr val="0B0B0B"/>
+                </a:solidFill>
+                <a:latin typeface="Arial"/>
+              </a:rPr>
+              <a:t>per-task</a:t>
+            </a:r>
+            <a:r>
+              <a:rPr sz="2270" b="0" i="0">
+                <a:solidFill>
+                  <a:srgbClr val="0B0B0B"/>
+                </a:solidFill>
+                <a:latin typeface="Arial"/>
+              </a:rPr>
+              <a:t> </a:t>
+            </a:r>
+            <a:r>
+              <a:rPr sz="2270" b="0" i="0">
+                <a:solidFill>
+                  <a:srgbClr val="0B0B0B"/>
+                </a:solidFill>
+                <a:latin typeface="Arial"/>
+              </a:rPr>
+              <a:t>adaptation</a:t>
+            </a:r>
+          </a:p>
+        </p:txBody>
+      </p:sp>
+      <p:sp>
+        <p:nvSpPr>
+          <p:cNvPr id="117" name="TextBox 116"/>
+          <p:cNvSpPr txBox="1"/>
+          <p:nvPr/>
+        </p:nvSpPr>
+        <p:spPr>
+          <a:xfrm>
+            <a:off x="24073775" y="40047936"/>
+            <a:ext cx="3252609" cy="288475"/>
+          </a:xfrm>
+          <a:prstGeom prst="rect">
+            <a:avLst/>
+          </a:prstGeom>
+          <a:noFill/>
+        </p:spPr>
+        <p:txBody>
+          <a:bodyPr wrap="none" lIns="0" rIns="0" tIns="0" bIns="0">
+            <a:spAutoFit/>
+          </a:bodyPr>
+          <a:lstStyle/>
+          <a:p>
+            <a:r>
+              <a:rPr sz="2270" b="0" i="0">
+                <a:solidFill>
+                  <a:srgbClr val="0B0B0B"/>
+                </a:solidFill>
+                <a:latin typeface="Arial"/>
+              </a:rPr>
+              <a:t>original</a:t>
+            </a:r>
+            <a:r>
+              <a:rPr sz="2270" b="0" i="0">
+                <a:solidFill>
+                  <a:srgbClr val="0B0B0B"/>
+                </a:solidFill>
+                <a:latin typeface="Arial"/>
+              </a:rPr>
+              <a:t> </a:t>
+            </a:r>
+            <a:r>
+              <a:rPr sz="2270" b="0" i="0">
+                <a:solidFill>
+                  <a:srgbClr val="0B0B0B"/>
+                </a:solidFill>
+                <a:latin typeface="Arial"/>
+              </a:rPr>
+              <a:t>research;</a:t>
+            </a:r>
+            <a:r>
+              <a:rPr sz="2270" b="0" i="0">
+                <a:solidFill>
+                  <a:srgbClr val="0B0B0B"/>
+                </a:solidFill>
+                <a:latin typeface="Arial"/>
+              </a:rPr>
+              <a:t> </a:t>
+            </a:r>
+            <a:r>
+              <a:rPr sz="2270" b="0" i="0">
+                <a:solidFill>
+                  <a:srgbClr val="0B0B0B"/>
+                </a:solidFill>
+                <a:latin typeface="Arial"/>
+              </a:rPr>
+              <a:t>explicit</a:t>
+            </a:r>
+          </a:p>
+        </p:txBody>
+      </p:sp>
+      <p:sp>
+        <p:nvSpPr>
+          <p:cNvPr id="118" name="TextBox 117"/>
+          <p:cNvSpPr txBox="1"/>
+          <p:nvPr/>
+        </p:nvSpPr>
+        <p:spPr>
+          <a:xfrm>
+            <a:off x="24073775" y="40414866"/>
+            <a:ext cx="3700901" cy="288475"/>
+          </a:xfrm>
+          <a:prstGeom prst="rect">
+            <a:avLst/>
+          </a:prstGeom>
+          <a:noFill/>
+        </p:spPr>
+        <p:txBody>
+          <a:bodyPr wrap="none" lIns="0" rIns="0" tIns="0" bIns="0">
+            <a:spAutoFit/>
+          </a:bodyPr>
+          <a:lstStyle/>
+          <a:p>
+            <a:r>
+              <a:rPr sz="2270" b="0" i="0">
+                <a:solidFill>
+                  <a:srgbClr val="0B0B0B"/>
+                </a:solidFill>
+                <a:latin typeface="Arial"/>
+              </a:rPr>
+              <a:t>hypotheses,</a:t>
+            </a:r>
+            <a:r>
+              <a:rPr sz="2270" b="0" i="0">
+                <a:solidFill>
+                  <a:srgbClr val="0B0B0B"/>
+                </a:solidFill>
+                <a:latin typeface="Arial"/>
+              </a:rPr>
+              <a:t> </a:t>
+            </a:r>
+            <a:r>
+              <a:rPr sz="2270" b="0" i="0">
+                <a:solidFill>
+                  <a:srgbClr val="0B0B0B"/>
+                </a:solidFill>
+                <a:latin typeface="Arial"/>
+              </a:rPr>
+              <a:t>tested</a:t>
+            </a:r>
+            <a:r>
+              <a:rPr sz="2270" b="0" i="0">
+                <a:solidFill>
+                  <a:srgbClr val="0B0B0B"/>
+                </a:solidFill>
+                <a:latin typeface="Arial"/>
+              </a:rPr>
+              <a:t> </a:t>
+            </a:r>
+            <a:r>
+              <a:rPr sz="2270" b="0" i="0">
+                <a:solidFill>
+                  <a:srgbClr val="0B0B0B"/>
+                </a:solidFill>
+                <a:latin typeface="Arial"/>
+              </a:rPr>
+              <a:t>revisions</a:t>
+            </a:r>
+          </a:p>
+        </p:txBody>
+      </p:sp>
+      <p:sp>
+        <p:nvSpPr>
+          <p:cNvPr id="119" name="TextBox 118"/>
+          <p:cNvSpPr txBox="1"/>
+          <p:nvPr/>
+        </p:nvSpPr>
+        <p:spPr>
+          <a:xfrm>
+            <a:off x="19529944" y="41172649"/>
+            <a:ext cx="9234247" cy="288714"/>
+          </a:xfrm>
+          <a:prstGeom prst="rect">
+            <a:avLst/>
+          </a:prstGeom>
+          <a:noFill/>
+        </p:spPr>
+        <p:txBody>
+          <a:bodyPr wrap="none" lIns="0" rIns="0" tIns="0" bIns="0">
+            <a:spAutoFit/>
+          </a:bodyPr>
+          <a:lstStyle/>
+          <a:p>
+            <a:r>
+              <a:rPr sz="2270" b="1" i="0">
+                <a:solidFill>
+                  <a:srgbClr val="0B0B0B"/>
+                </a:solidFill>
+                <a:latin typeface="Arial"/>
+              </a:rPr>
+              <a:t>Open</a:t>
+            </a:r>
+            <a:r>
+              <a:rPr sz="2270" b="1" i="0">
+                <a:solidFill>
+                  <a:srgbClr val="0B0B0B"/>
+                </a:solidFill>
+                <a:latin typeface="Arial"/>
+              </a:rPr>
+              <a:t> </a:t>
+            </a:r>
+            <a:r>
+              <a:rPr sz="2270" b="1" i="0">
+                <a:solidFill>
+                  <a:srgbClr val="0B0B0B"/>
+                </a:solidFill>
+                <a:latin typeface="Arial"/>
+              </a:rPr>
+              <a:t>question:</a:t>
+            </a:r>
+            <a:r>
+              <a:rPr sz="2270" b="0" i="0">
+                <a:solidFill>
+                  <a:srgbClr val="0B0B0B"/>
+                </a:solidFill>
+                <a:latin typeface="Arial"/>
+              </a:rPr>
+              <a:t> </a:t>
+            </a:r>
+            <a:r>
+              <a:rPr sz="2270" b="0" i="0">
+                <a:solidFill>
+                  <a:srgbClr val="0B0B0B"/>
+                </a:solidFill>
+                <a:latin typeface="Arial"/>
+              </a:rPr>
+              <a:t>can</a:t>
+            </a:r>
+            <a:r>
+              <a:rPr sz="2270" b="0" i="0">
+                <a:solidFill>
+                  <a:srgbClr val="0B0B0B"/>
+                </a:solidFill>
+                <a:latin typeface="Arial"/>
+              </a:rPr>
+              <a:t> </a:t>
+            </a:r>
+            <a:r>
+              <a:rPr sz="2270" b="0" i="0">
+                <a:solidFill>
+                  <a:srgbClr val="0B0B0B"/>
+                </a:solidFill>
+                <a:latin typeface="Arial"/>
+              </a:rPr>
+              <a:t>learned</a:t>
+            </a:r>
+            <a:r>
+              <a:rPr sz="2270" b="0" i="0">
+                <a:solidFill>
+                  <a:srgbClr val="0B0B0B"/>
+                </a:solidFill>
+                <a:latin typeface="Arial"/>
+              </a:rPr>
+              <a:t> </a:t>
+            </a:r>
+            <a:r>
+              <a:rPr sz="2270" b="0" i="0">
+                <a:solidFill>
+                  <a:srgbClr val="0B0B0B"/>
+                </a:solidFill>
+                <a:latin typeface="Arial"/>
+              </a:rPr>
+              <a:t>neural</a:t>
+            </a:r>
+            <a:r>
+              <a:rPr sz="2270" b="0" i="0">
+                <a:solidFill>
+                  <a:srgbClr val="0B0B0B"/>
+                </a:solidFill>
+                <a:latin typeface="Arial"/>
+              </a:rPr>
+              <a:t> </a:t>
+            </a:r>
+            <a:r>
+              <a:rPr sz="2270" b="0" i="0">
+                <a:solidFill>
+                  <a:srgbClr val="0B0B0B"/>
+                </a:solidFill>
+                <a:latin typeface="Arial"/>
+              </a:rPr>
+              <a:t>proposals</a:t>
+            </a:r>
+            <a:r>
+              <a:rPr sz="2270" b="0" i="0">
+                <a:solidFill>
+                  <a:srgbClr val="0B0B0B"/>
+                </a:solidFill>
+                <a:latin typeface="Arial"/>
+              </a:rPr>
+              <a:t> </a:t>
+            </a:r>
+            <a:r>
+              <a:rPr sz="2270" b="0" i="0">
+                <a:solidFill>
+                  <a:srgbClr val="0B0B0B"/>
+                </a:solidFill>
+                <a:latin typeface="Arial"/>
+              </a:rPr>
+              <a:t>help</a:t>
+            </a:r>
+            <a:r>
+              <a:rPr sz="2270" b="0" i="0">
+                <a:solidFill>
+                  <a:srgbClr val="0B0B0B"/>
+                </a:solidFill>
+                <a:latin typeface="Arial"/>
+              </a:rPr>
+              <a:t> </a:t>
+            </a:r>
+            <a:r>
+              <a:rPr sz="2270" b="0" i="0">
+                <a:solidFill>
+                  <a:srgbClr val="0B0B0B"/>
+                </a:solidFill>
+                <a:latin typeface="Arial"/>
+              </a:rPr>
+              <a:t>an</a:t>
+            </a:r>
+            <a:r>
+              <a:rPr sz="2270" b="0" i="0">
+                <a:solidFill>
+                  <a:srgbClr val="0B0B0B"/>
+                </a:solidFill>
+                <a:latin typeface="Arial"/>
+              </a:rPr>
+              <a:t> </a:t>
+            </a:r>
+            <a:r>
+              <a:rPr sz="2270" b="0" i="0">
+                <a:solidFill>
+                  <a:srgbClr val="0B0B0B"/>
+                </a:solidFill>
+                <a:latin typeface="Arial"/>
+              </a:rPr>
+              <a:t>executable</a:t>
+            </a:r>
+            <a:r>
+              <a:rPr sz="2270" b="0" i="0">
+                <a:solidFill>
+                  <a:srgbClr val="0B0B0B"/>
+                </a:solidFill>
+                <a:latin typeface="Arial"/>
+              </a:rPr>
+              <a:t> </a:t>
+            </a:r>
+            <a:r>
+              <a:rPr sz="2270" b="0" i="0">
+                <a:solidFill>
+                  <a:srgbClr val="0B0B0B"/>
+                </a:solidFill>
+                <a:latin typeface="Arial"/>
+              </a:rPr>
+              <a:t>rea-</a:t>
+            </a:r>
+          </a:p>
+        </p:txBody>
+      </p:sp>
+      <p:sp>
+        <p:nvSpPr>
+          <p:cNvPr id="120" name="TextBox 119"/>
+          <p:cNvSpPr txBox="1"/>
+          <p:nvPr/>
+        </p:nvSpPr>
+        <p:spPr>
+          <a:xfrm>
+            <a:off x="19529944" y="41539579"/>
+            <a:ext cx="6185256" cy="288475"/>
+          </a:xfrm>
+          <a:prstGeom prst="rect">
+            <a:avLst/>
+          </a:prstGeom>
+          <a:noFill/>
+        </p:spPr>
+        <p:txBody>
+          <a:bodyPr wrap="none" lIns="0" rIns="0" tIns="0" bIns="0">
+            <a:spAutoFit/>
+          </a:bodyPr>
+          <a:lstStyle/>
+          <a:p>
+            <a:r>
+              <a:rPr sz="2270" b="0" i="0">
+                <a:solidFill>
+                  <a:srgbClr val="0B0B0B"/>
+                </a:solidFill>
+                <a:latin typeface="Arial"/>
+              </a:rPr>
+              <a:t>soner</a:t>
+            </a:r>
+            <a:r>
+              <a:rPr sz="2270" b="0" i="0">
+                <a:solidFill>
+                  <a:srgbClr val="0B0B0B"/>
+                </a:solidFill>
+                <a:latin typeface="Arial"/>
+              </a:rPr>
+              <a:t> </a:t>
+            </a:r>
+            <a:r>
+              <a:rPr sz="2270" b="0" i="0">
+                <a:solidFill>
+                  <a:srgbClr val="0B0B0B"/>
+                </a:solidFill>
+                <a:latin typeface="Arial"/>
+              </a:rPr>
+              <a:t>find</a:t>
+            </a:r>
+            <a:r>
+              <a:rPr sz="2270" b="0" i="0">
+                <a:solidFill>
+                  <a:srgbClr val="0B0B0B"/>
+                </a:solidFill>
+                <a:latin typeface="Arial"/>
+              </a:rPr>
+              <a:t> </a:t>
+            </a:r>
+            <a:r>
+              <a:rPr sz="2270" b="0" i="0">
+                <a:solidFill>
+                  <a:srgbClr val="0B0B0B"/>
+                </a:solidFill>
+                <a:latin typeface="Arial"/>
+              </a:rPr>
+              <a:t>which</a:t>
+            </a:r>
+            <a:r>
+              <a:rPr sz="2270" b="0" i="0">
+                <a:solidFill>
+                  <a:srgbClr val="0B0B0B"/>
+                </a:solidFill>
+                <a:latin typeface="Arial"/>
+              </a:rPr>
+              <a:t> </a:t>
+            </a:r>
+            <a:r>
+              <a:rPr sz="2270" b="0" i="0">
+                <a:solidFill>
+                  <a:srgbClr val="0B0B0B"/>
+                </a:solidFill>
+                <a:latin typeface="Arial"/>
+              </a:rPr>
+              <a:t>part</a:t>
+            </a:r>
+            <a:r>
+              <a:rPr sz="2270" b="0" i="0">
+                <a:solidFill>
+                  <a:srgbClr val="0B0B0B"/>
+                </a:solidFill>
+                <a:latin typeface="Arial"/>
+              </a:rPr>
+              <a:t> </a:t>
+            </a:r>
+            <a:r>
+              <a:rPr sz="2270" b="0" i="0">
+                <a:solidFill>
+                  <a:srgbClr val="0B0B0B"/>
+                </a:solidFill>
+                <a:latin typeface="Arial"/>
+              </a:rPr>
+              <a:t>of</a:t>
+            </a:r>
+            <a:r>
+              <a:rPr sz="2270" b="0" i="0">
+                <a:solidFill>
+                  <a:srgbClr val="0B0B0B"/>
+                </a:solidFill>
+                <a:latin typeface="Arial"/>
+              </a:rPr>
+              <a:t> </a:t>
+            </a:r>
+            <a:r>
+              <a:rPr sz="2270" b="0" i="0">
+                <a:solidFill>
+                  <a:srgbClr val="0B0B0B"/>
+                </a:solidFill>
+                <a:latin typeface="Arial"/>
+              </a:rPr>
+              <a:t>a</a:t>
+            </a:r>
+            <a:r>
+              <a:rPr sz="2270" b="0" i="0">
+                <a:solidFill>
+                  <a:srgbClr val="0B0B0B"/>
+                </a:solidFill>
+                <a:latin typeface="Arial"/>
+              </a:rPr>
+              <a:t> </a:t>
+            </a:r>
+            <a:r>
+              <a:rPr sz="2270" b="0" i="0">
+                <a:solidFill>
+                  <a:srgbClr val="0B0B0B"/>
+                </a:solidFill>
+                <a:latin typeface="Arial"/>
+              </a:rPr>
+              <a:t>hypothesis</a:t>
+            </a:r>
+            <a:r>
+              <a:rPr sz="2270" b="0" i="0">
+                <a:solidFill>
+                  <a:srgbClr val="0B0B0B"/>
+                </a:solidFill>
+                <a:latin typeface="Arial"/>
+              </a:rPr>
+              <a:t> </a:t>
+            </a:r>
+            <a:r>
+              <a:rPr sz="2270" b="0" i="0">
+                <a:solidFill>
+                  <a:srgbClr val="0B0B0B"/>
+                </a:solidFill>
+                <a:latin typeface="Arial"/>
+              </a:rPr>
+              <a:t>to</a:t>
+            </a:r>
+            <a:r>
+              <a:rPr sz="2270" b="0" i="0">
+                <a:solidFill>
+                  <a:srgbClr val="0B0B0B"/>
+                </a:solidFill>
+                <a:latin typeface="Arial"/>
+              </a:rPr>
+              <a:t> </a:t>
+            </a:r>
+            <a:r>
+              <a:rPr sz="2270" b="0" i="0">
+                <a:solidFill>
+                  <a:srgbClr val="0B0B0B"/>
+                </a:solidFill>
+                <a:latin typeface="Arial"/>
+              </a:rPr>
+              <a:t>revise?</a:t>
+            </a:r>
+          </a:p>
+        </p:txBody>
+      </p:sp>
+      <p:sp>
+        <p:nvSpPr>
+          <p:cNvPr id="121" name="TextBox 120"/>
+          <p:cNvSpPr txBox="1"/>
+          <p:nvPr/>
+        </p:nvSpPr>
+        <p:spPr>
+          <a:xfrm>
+            <a:off x="936003" y="42230048"/>
+            <a:ext cx="28454909" cy="264439"/>
+          </a:xfrm>
+          <a:prstGeom prst="rect">
+            <a:avLst/>
+          </a:prstGeom>
+          <a:noFill/>
+        </p:spPr>
+        <p:txBody>
+          <a:bodyPr wrap="none" lIns="0" rIns="0" tIns="0" bIns="0">
+            <a:spAutoFit/>
+          </a:bodyPr>
+          <a:lstStyle/>
+          <a:p>
+            <a:r>
+              <a:rPr sz="2080" b="0" i="0">
+                <a:solidFill>
+                  <a:srgbClr val="52514E"/>
+                </a:solidFill>
+                <a:latin typeface="Arial"/>
+              </a:rPr>
+              <a:t>Related work:</a:t>
+            </a:r>
+            <a:r>
+              <a:rPr sz="2080" b="0" i="0">
+                <a:solidFill>
+                  <a:srgbClr val="52514E"/>
+                </a:solidFill>
+                <a:latin typeface="Arial"/>
+              </a:rPr>
+              <a:t> </a:t>
+            </a:r>
+            <a:r>
+              <a:rPr sz="2080" b="0" i="0">
+                <a:solidFill>
+                  <a:srgbClr val="52514E"/>
+                </a:solidFill>
+                <a:latin typeface="Arial"/>
+              </a:rPr>
+              <a:t>Popper (Cropper &amp; Morel 2021); DreamCoder (Ellis et al. 2021); LILO (Grand et al. 2024); Model Discovery Agent (Murphy 2026).</a:t>
+            </a:r>
+            <a:r>
+              <a:rPr sz="2080" b="0" i="0">
+                <a:solidFill>
+                  <a:srgbClr val="52514E"/>
+                </a:solidFill>
+                <a:latin typeface="Arial"/>
+              </a:rPr>
+              <a:t> </a:t>
+            </a:r>
+            <a:r>
+              <a:rPr sz="2080" b="0" i="0">
+                <a:solidFill>
+                  <a:srgbClr val="52514E"/>
+                </a:solidFill>
+                <a:latin typeface="Arial"/>
+              </a:rPr>
+              <a:t>The failure-to-revision idea is not new; the question is which component to revise, against matched</a:t>
+            </a:r>
+          </a:p>
+        </p:txBody>
+      </p:sp>
+      <p:sp>
+        <p:nvSpPr>
+          <p:cNvPr id="122" name="TextBox 121"/>
+          <p:cNvSpPr txBox="1"/>
+          <p:nvPr/>
+        </p:nvSpPr>
+        <p:spPr>
+          <a:xfrm>
+            <a:off x="936003" y="42566725"/>
             <a:ext cx="20198843" cy="282671"/>
           </a:xfrm>
           <a:prstGeom prst="rect">

</xml_diff>